<commit_message>
feat(main): make course structure
</commit_message>
<xml_diff>
--- a/labs/lab03/presentation/output/os-intro-lab03-presentation.pptx
+++ b/labs/lab03/presentation/output/os-intro-lab03-presentation.pptx
@@ -3270,15 +3270,6 @@
             <a:r>
               <a:rPr/>
               <a:t>Мы научились оформлять отчёты с помощью легковесного языка разметки Markdown.</a:t>
-            </a:r>
-          </a:p>
-          <a:p>
-            <a:pPr lvl="0" indent="0" marL="0">
-              <a:buNone/>
-            </a:pPr>
-            <a:r>
-              <a:rPr/>
-              <a:t>Теперь презентация полностью соответствует структуре первых двух лабораторных работ.</a:t>
             </a:r>
           </a:p>
         </p:txBody>

</xml_diff>